<commit_message>
Add attribution and copyright to the deck
Title slide credits Paul J. Clark (conceived) and Claude Fable 5 (compiled);
adds "(c) Paul J. Clark 2026" to the title slide and every content footer.

Co-Authored-By: Claude Opus 4.8 (1M context) <noreply@anthropic.com>
</commit_message>
<xml_diff>
--- a/The-Light-of-33-AD.pptx
+++ b/The-Light-of-33-AD.pptx
@@ -1787,7 +1787,7 @@
         </p:nvSpPr>
         <p:spPr>
           <a:xfrm>
-            <a:off x="2026768" y="5257800"/>
+            <a:off x="2026768" y="5029200"/>
             <a:ext cx="2468880" cy="777240"/>
           </a:xfrm>
           <a:prstGeom prst="rect">
@@ -1849,7 +1849,7 @@
         </p:nvSpPr>
         <p:spPr>
           <a:xfrm>
-            <a:off x="4861408" y="5257800"/>
+            <a:off x="4861408" y="5029200"/>
             <a:ext cx="2468880" cy="777240"/>
           </a:xfrm>
           <a:prstGeom prst="rect">
@@ -1911,7 +1911,7 @@
         </p:nvSpPr>
         <p:spPr>
           <a:xfrm>
-            <a:off x="7696048" y="5257800"/>
+            <a:off x="7696048" y="5029200"/>
             <a:ext cx="2468880" cy="777240"/>
           </a:xfrm>
           <a:prstGeom prst="rect">
@@ -1962,6 +1962,107 @@
               <a:t>NEVER DESTROYED</a:t>
             </a:r>
             <a:endParaRPr lang="en-US" sz="2000" dirty="0"/>
+          </a:p>
+        </p:txBody>
+      </p:sp>
+      <p:sp>
+        <p:nvSpPr>
+          <p:cNvPr id="10" name="Text 7"/>
+          <p:cNvSpPr/>
+          <p:nvPr/>
+        </p:nvSpPr>
+        <p:spPr>
+          <a:xfrm>
+            <a:off x="1371600" y="5806440"/>
+            <a:ext cx="9445752" cy="548640"/>
+          </a:xfrm>
+          <a:prstGeom prst="rect">
+            <a:avLst/>
+          </a:prstGeom>
+          <a:noFill/>
+          <a:ln/>
+        </p:spPr>
+        <p:txBody>
+          <a:bodyPr wrap="square" lIns="0" tIns="0" rIns="0" bIns="0" rtlCol="0" anchor="ctr"/>
+          <a:lstStyle/>
+          <a:p>
+            <a:pPr algn="ctr" indent="0" marL="0">
+              <a:lnSpc>
+                <a:spcPts val="1900"/>
+              </a:lnSpc>
+              <a:buNone/>
+            </a:pPr>
+            <a:r>
+              <a:rPr lang="en-US" sz="1250" i="1" dirty="0">
+                <a:solidFill>
+                  <a:srgbClr val="7E8CA3"/>
+                </a:solidFill>
+                <a:latin typeface="Georgia" pitchFamily="34" charset="0"/>
+                <a:ea typeface="Georgia" pitchFamily="34" charset="-122"/>
+                <a:cs typeface="Georgia" pitchFamily="34" charset="-120"/>
+              </a:rPr>
+              <a:t>Thought experiment conceived by Paul J. Clark on July 7, 2026.</a:t>
+            </a:r>
+            <a:endParaRPr lang="en-US" sz="1250" dirty="0"/>
+          </a:p>
+          <a:p>
+            <a:pPr algn="ctr" indent="0" marL="0">
+              <a:lnSpc>
+                <a:spcPts val="1900"/>
+              </a:lnSpc>
+              <a:buNone/>
+            </a:pPr>
+            <a:r>
+              <a:rPr lang="en-US" sz="1250" i="1" dirty="0">
+                <a:solidFill>
+                  <a:srgbClr val="7E8CA3"/>
+                </a:solidFill>
+                <a:latin typeface="Georgia" pitchFamily="34" charset="0"/>
+                <a:ea typeface="Georgia" pitchFamily="34" charset="-122"/>
+                <a:cs typeface="Georgia" pitchFamily="34" charset="-120"/>
+              </a:rPr>
+              <a:t>Researched and compiled by Claude Fable 5 on July 7, 2026.</a:t>
+            </a:r>
+            <a:endParaRPr lang="en-US" sz="1250" dirty="0"/>
+          </a:p>
+        </p:txBody>
+      </p:sp>
+      <p:sp>
+        <p:nvSpPr>
+          <p:cNvPr id="11" name="Text 8"/>
+          <p:cNvSpPr/>
+          <p:nvPr/>
+        </p:nvSpPr>
+        <p:spPr>
+          <a:xfrm>
+            <a:off x="1371600" y="6446520"/>
+            <a:ext cx="9445752" cy="274320"/>
+          </a:xfrm>
+          <a:prstGeom prst="rect">
+            <a:avLst/>
+          </a:prstGeom>
+          <a:noFill/>
+          <a:ln/>
+        </p:spPr>
+        <p:txBody>
+          <a:bodyPr wrap="square" lIns="0" tIns="0" rIns="0" bIns="0" rtlCol="0" anchor="ctr"/>
+          <a:lstStyle/>
+          <a:p>
+            <a:pPr algn="ctr" indent="0" marL="0">
+              <a:buNone/>
+            </a:pPr>
+            <a:r>
+              <a:rPr lang="en-US" sz="1000" spc="100" kern="0" dirty="0">
+                <a:solidFill>
+                  <a:srgbClr val="7E8CA3"/>
+                </a:solidFill>
+                <a:latin typeface="Consolas" pitchFamily="34" charset="0"/>
+                <a:ea typeface="Consolas" pitchFamily="34" charset="-122"/>
+                <a:cs typeface="Consolas" pitchFamily="34" charset="-120"/>
+              </a:rPr>
+              <a:t>© Paul J. Clark 2026</a:t>
+            </a:r>
+            <a:endParaRPr lang="en-US" sz="1000" dirty="0"/>
           </a:p>
         </p:txBody>
       </p:sp>
@@ -2683,7 +2784,7 @@
         <p:spPr>
           <a:xfrm>
             <a:off x="640080" y="6473952"/>
-            <a:ext cx="7315200" cy="274320"/>
+            <a:ext cx="5486400" cy="274320"/>
           </a:xfrm>
           <a:prstGeom prst="rect">
             <a:avLst/>
@@ -2716,6 +2817,45 @@
       <p:sp>
         <p:nvSpPr>
           <p:cNvPr id="23" name="Text 18"/>
+          <p:cNvSpPr/>
+          <p:nvPr/>
+        </p:nvSpPr>
+        <p:spPr>
+          <a:xfrm>
+            <a:off x="3657600" y="6473952"/>
+            <a:ext cx="4873752" cy="274320"/>
+          </a:xfrm>
+          <a:prstGeom prst="rect">
+            <a:avLst/>
+          </a:prstGeom>
+          <a:noFill/>
+          <a:ln/>
+        </p:spPr>
+        <p:txBody>
+          <a:bodyPr wrap="square" lIns="0" tIns="0" rIns="0" bIns="0" rtlCol="0" anchor="ctr"/>
+          <a:lstStyle/>
+          <a:p>
+            <a:pPr algn="ctr" indent="0" marL="0">
+              <a:buNone/>
+            </a:pPr>
+            <a:r>
+              <a:rPr lang="en-US" sz="900" dirty="0">
+                <a:solidFill>
+                  <a:srgbClr val="7E8CA3"/>
+                </a:solidFill>
+                <a:latin typeface="Consolas" pitchFamily="34" charset="0"/>
+                <a:ea typeface="Consolas" pitchFamily="34" charset="-122"/>
+                <a:cs typeface="Consolas" pitchFamily="34" charset="-120"/>
+              </a:rPr>
+              <a:t>© Paul J. Clark 2026</a:t>
+            </a:r>
+            <a:endParaRPr lang="en-US" sz="900" dirty="0"/>
+          </a:p>
+        </p:txBody>
+      </p:sp>
+      <p:sp>
+        <p:nvSpPr>
+          <p:cNvPr id="24" name="Text 19"/>
           <p:cNvSpPr/>
           <p:nvPr/>
         </p:nvSpPr>
@@ -3245,7 +3385,7 @@
         <p:spPr>
           <a:xfrm>
             <a:off x="640080" y="6473952"/>
-            <a:ext cx="7315200" cy="274320"/>
+            <a:ext cx="5486400" cy="274320"/>
           </a:xfrm>
           <a:prstGeom prst="rect">
             <a:avLst/>
@@ -3278,6 +3418,45 @@
       <p:sp>
         <p:nvSpPr>
           <p:cNvPr id="14" name="Text 11"/>
+          <p:cNvSpPr/>
+          <p:nvPr/>
+        </p:nvSpPr>
+        <p:spPr>
+          <a:xfrm>
+            <a:off x="3657600" y="6473952"/>
+            <a:ext cx="4873752" cy="274320"/>
+          </a:xfrm>
+          <a:prstGeom prst="rect">
+            <a:avLst/>
+          </a:prstGeom>
+          <a:noFill/>
+          <a:ln/>
+        </p:spPr>
+        <p:txBody>
+          <a:bodyPr wrap="square" lIns="0" tIns="0" rIns="0" bIns="0" rtlCol="0" anchor="ctr"/>
+          <a:lstStyle/>
+          <a:p>
+            <a:pPr algn="ctr" indent="0" marL="0">
+              <a:buNone/>
+            </a:pPr>
+            <a:r>
+              <a:rPr lang="en-US" sz="900" dirty="0">
+                <a:solidFill>
+                  <a:srgbClr val="7E8CA3"/>
+                </a:solidFill>
+                <a:latin typeface="Consolas" pitchFamily="34" charset="0"/>
+                <a:ea typeface="Consolas" pitchFamily="34" charset="-122"/>
+                <a:cs typeface="Consolas" pitchFamily="34" charset="-120"/>
+              </a:rPr>
+              <a:t>© Paul J. Clark 2026</a:t>
+            </a:r>
+            <a:endParaRPr lang="en-US" sz="900" dirty="0"/>
+          </a:p>
+        </p:txBody>
+      </p:sp>
+      <p:sp>
+        <p:nvSpPr>
+          <p:cNvPr id="15" name="Text 12"/>
           <p:cNvSpPr/>
           <p:nvPr/>
         </p:nvSpPr>
@@ -4724,7 +4903,7 @@
         <p:spPr>
           <a:xfrm>
             <a:off x="640080" y="6473952"/>
-            <a:ext cx="7315200" cy="274320"/>
+            <a:ext cx="5486400" cy="274320"/>
           </a:xfrm>
           <a:prstGeom prst="rect">
             <a:avLst/>
@@ -4757,6 +4936,45 @@
       <p:sp>
         <p:nvSpPr>
           <p:cNvPr id="37" name="Text 35"/>
+          <p:cNvSpPr/>
+          <p:nvPr/>
+        </p:nvSpPr>
+        <p:spPr>
+          <a:xfrm>
+            <a:off x="3657600" y="6473952"/>
+            <a:ext cx="4873752" cy="274320"/>
+          </a:xfrm>
+          <a:prstGeom prst="rect">
+            <a:avLst/>
+          </a:prstGeom>
+          <a:noFill/>
+          <a:ln/>
+        </p:spPr>
+        <p:txBody>
+          <a:bodyPr wrap="square" lIns="0" tIns="0" rIns="0" bIns="0" rtlCol="0" anchor="ctr"/>
+          <a:lstStyle/>
+          <a:p>
+            <a:pPr algn="ctr" indent="0" marL="0">
+              <a:buNone/>
+            </a:pPr>
+            <a:r>
+              <a:rPr lang="en-US" sz="900" dirty="0">
+                <a:solidFill>
+                  <a:srgbClr val="7E8CA3"/>
+                </a:solidFill>
+                <a:latin typeface="Consolas" pitchFamily="34" charset="0"/>
+                <a:ea typeface="Consolas" pitchFamily="34" charset="-122"/>
+                <a:cs typeface="Consolas" pitchFamily="34" charset="-120"/>
+              </a:rPr>
+              <a:t>© Paul J. Clark 2026</a:t>
+            </a:r>
+            <a:endParaRPr lang="en-US" sz="900" dirty="0"/>
+          </a:p>
+        </p:txBody>
+      </p:sp>
+      <p:sp>
+        <p:nvSpPr>
+          <p:cNvPr id="38" name="Text 36"/>
           <p:cNvSpPr/>
           <p:nvPr/>
         </p:nvSpPr>
@@ -5543,7 +5761,7 @@
         <p:spPr>
           <a:xfrm>
             <a:off x="640080" y="6473952"/>
-            <a:ext cx="7315200" cy="274320"/>
+            <a:ext cx="5486400" cy="274320"/>
           </a:xfrm>
           <a:prstGeom prst="rect">
             <a:avLst/>
@@ -5576,6 +5794,45 @@
       <p:sp>
         <p:nvSpPr>
           <p:cNvPr id="23" name="Text 20"/>
+          <p:cNvSpPr/>
+          <p:nvPr/>
+        </p:nvSpPr>
+        <p:spPr>
+          <a:xfrm>
+            <a:off x="3657600" y="6473952"/>
+            <a:ext cx="4873752" cy="274320"/>
+          </a:xfrm>
+          <a:prstGeom prst="rect">
+            <a:avLst/>
+          </a:prstGeom>
+          <a:noFill/>
+          <a:ln/>
+        </p:spPr>
+        <p:txBody>
+          <a:bodyPr wrap="square" lIns="0" tIns="0" rIns="0" bIns="0" rtlCol="0" anchor="ctr"/>
+          <a:lstStyle/>
+          <a:p>
+            <a:pPr algn="ctr" indent="0" marL="0">
+              <a:buNone/>
+            </a:pPr>
+            <a:r>
+              <a:rPr lang="en-US" sz="900" dirty="0">
+                <a:solidFill>
+                  <a:srgbClr val="7E8CA3"/>
+                </a:solidFill>
+                <a:latin typeface="Consolas" pitchFamily="34" charset="0"/>
+                <a:ea typeface="Consolas" pitchFamily="34" charset="-122"/>
+                <a:cs typeface="Consolas" pitchFamily="34" charset="-120"/>
+              </a:rPr>
+              <a:t>© Paul J. Clark 2026</a:t>
+            </a:r>
+            <a:endParaRPr lang="en-US" sz="900" dirty="0"/>
+          </a:p>
+        </p:txBody>
+      </p:sp>
+      <p:sp>
+        <p:nvSpPr>
+          <p:cNvPr id="24" name="Text 21"/>
           <p:cNvSpPr/>
           <p:nvPr/>
         </p:nvSpPr>
@@ -6613,7 +6870,7 @@
         <p:spPr>
           <a:xfrm>
             <a:off x="640080" y="6473952"/>
-            <a:ext cx="7315200" cy="274320"/>
+            <a:ext cx="5486400" cy="274320"/>
           </a:xfrm>
           <a:prstGeom prst="rect">
             <a:avLst/>
@@ -6646,6 +6903,45 @@
       <p:sp>
         <p:nvSpPr>
           <p:cNvPr id="33" name="Text 28"/>
+          <p:cNvSpPr/>
+          <p:nvPr/>
+        </p:nvSpPr>
+        <p:spPr>
+          <a:xfrm>
+            <a:off x="3657600" y="6473952"/>
+            <a:ext cx="4873752" cy="274320"/>
+          </a:xfrm>
+          <a:prstGeom prst="rect">
+            <a:avLst/>
+          </a:prstGeom>
+          <a:noFill/>
+          <a:ln/>
+        </p:spPr>
+        <p:txBody>
+          <a:bodyPr wrap="square" lIns="0" tIns="0" rIns="0" bIns="0" rtlCol="0" anchor="ctr"/>
+          <a:lstStyle/>
+          <a:p>
+            <a:pPr algn="ctr" indent="0" marL="0">
+              <a:buNone/>
+            </a:pPr>
+            <a:r>
+              <a:rPr lang="en-US" sz="900" dirty="0">
+                <a:solidFill>
+                  <a:srgbClr val="7E8CA3"/>
+                </a:solidFill>
+                <a:latin typeface="Consolas" pitchFamily="34" charset="0"/>
+                <a:ea typeface="Consolas" pitchFamily="34" charset="-122"/>
+                <a:cs typeface="Consolas" pitchFamily="34" charset="-120"/>
+              </a:rPr>
+              <a:t>© Paul J. Clark 2026</a:t>
+            </a:r>
+            <a:endParaRPr lang="en-US" sz="900" dirty="0"/>
+          </a:p>
+        </p:txBody>
+      </p:sp>
+      <p:sp>
+        <p:nvSpPr>
+          <p:cNvPr id="34" name="Text 29"/>
           <p:cNvSpPr/>
           <p:nvPr/>
         </p:nvSpPr>
@@ -7036,7 +7332,7 @@
         <p:spPr>
           <a:xfrm>
             <a:off x="640080" y="6473952"/>
-            <a:ext cx="7315200" cy="274320"/>
+            <a:ext cx="5486400" cy="274320"/>
           </a:xfrm>
           <a:prstGeom prst="rect">
             <a:avLst/>
@@ -7069,6 +7365,45 @@
       <p:sp>
         <p:nvSpPr>
           <p:cNvPr id="12" name="Text 9"/>
+          <p:cNvSpPr/>
+          <p:nvPr/>
+        </p:nvSpPr>
+        <p:spPr>
+          <a:xfrm>
+            <a:off x="3657600" y="6473952"/>
+            <a:ext cx="4873752" cy="274320"/>
+          </a:xfrm>
+          <a:prstGeom prst="rect">
+            <a:avLst/>
+          </a:prstGeom>
+          <a:noFill/>
+          <a:ln/>
+        </p:spPr>
+        <p:txBody>
+          <a:bodyPr wrap="square" lIns="0" tIns="0" rIns="0" bIns="0" rtlCol="0" anchor="ctr"/>
+          <a:lstStyle/>
+          <a:p>
+            <a:pPr algn="ctr" indent="0" marL="0">
+              <a:buNone/>
+            </a:pPr>
+            <a:r>
+              <a:rPr lang="en-US" sz="900" dirty="0">
+                <a:solidFill>
+                  <a:srgbClr val="7E8CA3"/>
+                </a:solidFill>
+                <a:latin typeface="Consolas" pitchFamily="34" charset="0"/>
+                <a:ea typeface="Consolas" pitchFamily="34" charset="-122"/>
+                <a:cs typeface="Consolas" pitchFamily="34" charset="-120"/>
+              </a:rPr>
+              <a:t>© Paul J. Clark 2026</a:t>
+            </a:r>
+            <a:endParaRPr lang="en-US" sz="900" dirty="0"/>
+          </a:p>
+        </p:txBody>
+      </p:sp>
+      <p:sp>
+        <p:nvSpPr>
+          <p:cNvPr id="13" name="Text 10"/>
           <p:cNvSpPr/>
           <p:nvPr/>
         </p:nvSpPr>
@@ -7635,7 +7970,7 @@
         <p:spPr>
           <a:xfrm>
             <a:off x="640080" y="6473952"/>
-            <a:ext cx="7315200" cy="274320"/>
+            <a:ext cx="5486400" cy="274320"/>
           </a:xfrm>
           <a:prstGeom prst="rect">
             <a:avLst/>
@@ -7668,6 +8003,45 @@
       <p:sp>
         <p:nvSpPr>
           <p:cNvPr id="18" name="Text 14"/>
+          <p:cNvSpPr/>
+          <p:nvPr/>
+        </p:nvSpPr>
+        <p:spPr>
+          <a:xfrm>
+            <a:off x="3657600" y="6473952"/>
+            <a:ext cx="4873752" cy="274320"/>
+          </a:xfrm>
+          <a:prstGeom prst="rect">
+            <a:avLst/>
+          </a:prstGeom>
+          <a:noFill/>
+          <a:ln/>
+        </p:spPr>
+        <p:txBody>
+          <a:bodyPr wrap="square" lIns="0" tIns="0" rIns="0" bIns="0" rtlCol="0" anchor="ctr"/>
+          <a:lstStyle/>
+          <a:p>
+            <a:pPr algn="ctr" indent="0" marL="0">
+              <a:buNone/>
+            </a:pPr>
+            <a:r>
+              <a:rPr lang="en-US" sz="900" dirty="0">
+                <a:solidFill>
+                  <a:srgbClr val="7E8CA3"/>
+                </a:solidFill>
+                <a:latin typeface="Consolas" pitchFamily="34" charset="0"/>
+                <a:ea typeface="Consolas" pitchFamily="34" charset="-122"/>
+                <a:cs typeface="Consolas" pitchFamily="34" charset="-120"/>
+              </a:rPr>
+              <a:t>© Paul J. Clark 2026</a:t>
+            </a:r>
+            <a:endParaRPr lang="en-US" sz="900" dirty="0"/>
+          </a:p>
+        </p:txBody>
+      </p:sp>
+      <p:sp>
+        <p:nvSpPr>
+          <p:cNvPr id="19" name="Text 15"/>
           <p:cNvSpPr/>
           <p:nvPr/>
         </p:nvSpPr>
@@ -8556,7 +8930,7 @@
         <p:spPr>
           <a:xfrm>
             <a:off x="640080" y="6473952"/>
-            <a:ext cx="7315200" cy="274320"/>
+            <a:ext cx="5486400" cy="274320"/>
           </a:xfrm>
           <a:prstGeom prst="rect">
             <a:avLst/>
@@ -8589,6 +8963,45 @@
       <p:sp>
         <p:nvSpPr>
           <p:cNvPr id="25" name="Text 23"/>
+          <p:cNvSpPr/>
+          <p:nvPr/>
+        </p:nvSpPr>
+        <p:spPr>
+          <a:xfrm>
+            <a:off x="3657600" y="6473952"/>
+            <a:ext cx="4873752" cy="274320"/>
+          </a:xfrm>
+          <a:prstGeom prst="rect">
+            <a:avLst/>
+          </a:prstGeom>
+          <a:noFill/>
+          <a:ln/>
+        </p:spPr>
+        <p:txBody>
+          <a:bodyPr wrap="square" lIns="0" tIns="0" rIns="0" bIns="0" rtlCol="0" anchor="ctr"/>
+          <a:lstStyle/>
+          <a:p>
+            <a:pPr algn="ctr" indent="0" marL="0">
+              <a:buNone/>
+            </a:pPr>
+            <a:r>
+              <a:rPr lang="en-US" sz="900" dirty="0">
+                <a:solidFill>
+                  <a:srgbClr val="7E8CA3"/>
+                </a:solidFill>
+                <a:latin typeface="Consolas" pitchFamily="34" charset="0"/>
+                <a:ea typeface="Consolas" pitchFamily="34" charset="-122"/>
+                <a:cs typeface="Consolas" pitchFamily="34" charset="-120"/>
+              </a:rPr>
+              <a:t>© Paul J. Clark 2026</a:t>
+            </a:r>
+            <a:endParaRPr lang="en-US" sz="900" dirty="0"/>
+          </a:p>
+        </p:txBody>
+      </p:sp>
+      <p:sp>
+        <p:nvSpPr>
+          <p:cNvPr id="26" name="Text 24"/>
           <p:cNvSpPr/>
           <p:nvPr/>
         </p:nvSpPr>

</xml_diff>